<commit_message>
update detail on slides
</commit_message>
<xml_diff>
--- a/classes/01-24-aug-intro/slides/model-classification.pptx
+++ b/classes/01-24-aug-intro/slides/model-classification.pptx
@@ -131,7 +131,7 @@
 <file path=ppt/revisionInfo.xml><?xml version="1.0" encoding="utf-8"?>
 <p1510:revInfo xmlns:a="http://schemas.openxmlformats.org/drawingml/2006/main" xmlns:r="http://schemas.openxmlformats.org/officeDocument/2006/relationships" xmlns:p1510="http://schemas.microsoft.com/office/powerpoint/2015/10/main">
   <p1510:revLst>
-    <p1510:client id="{C601D3EA-FB1C-4675-B46A-CB37089C09B1}" v="45" dt="2026-08-03T14:04:44.584"/>
+    <p1510:client id="{3A3EB6BD-8AFA-430B-A5C7-68FE9DED0E49}" v="1" dt="2026-08-19T08:55:01.348"/>
   </p1510:revLst>
 </p1510:revInfo>
 </file>
@@ -140,8 +140,8 @@
 <pc:chgInfo xmlns:a="http://schemas.openxmlformats.org/drawingml/2006/main" xmlns:r="http://schemas.openxmlformats.org/officeDocument/2006/relationships" xmlns:ac="http://schemas.microsoft.com/office/drawing/2013/main/command" xmlns:pc="http://schemas.microsoft.com/office/powerpoint/2013/main/command">
   <pc:docChgLst>
     <pc:chgData name="Frederik Rask Dalby" userId="12c7c68b-47c4-4858-a883-dbd84be7356f" providerId="ADAL" clId="{E9883B15-7D20-4C63-9A3F-08E95C9A44CC}"/>
-    <pc:docChg chg="custSel addSld delSld modSld sldOrd">
-      <pc:chgData name="Frederik Rask Dalby" userId="12c7c68b-47c4-4858-a883-dbd84be7356f" providerId="ADAL" clId="{E9883B15-7D20-4C63-9A3F-08E95C9A44CC}" dt="2026-08-03T14:05:27.660" v="432" actId="1076"/>
+    <pc:docChg chg="undo custSel addSld delSld modSld sldOrd">
+      <pc:chgData name="Frederik Rask Dalby" userId="12c7c68b-47c4-4858-a883-dbd84be7356f" providerId="ADAL" clId="{E9883B15-7D20-4C63-9A3F-08E95C9A44CC}" dt="2026-08-19T08:55:01.348" v="452"/>
       <pc:docMkLst>
         <pc:docMk/>
       </pc:docMkLst>
@@ -166,14 +166,6 @@
           <pc:docMk/>
           <pc:sldMk cId="2126172265" sldId="257"/>
         </pc:sldMkLst>
-        <pc:spChg chg="del">
-          <ac:chgData name="Frederik Rask Dalby" userId="12c7c68b-47c4-4858-a883-dbd84be7356f" providerId="ADAL" clId="{E9883B15-7D20-4C63-9A3F-08E95C9A44CC}" dt="2026-08-03T14:03:42.406" v="382" actId="478"/>
-          <ac:spMkLst>
-            <pc:docMk/>
-            <pc:sldMk cId="2126172265" sldId="257"/>
-            <ac:spMk id="2" creationId="{8F723E57-EB71-259D-37D7-D4EFFF9F254C}"/>
-          </ac:spMkLst>
-        </pc:spChg>
         <pc:spChg chg="add mod">
           <ac:chgData name="Frederik Rask Dalby" userId="12c7c68b-47c4-4858-a883-dbd84be7356f" providerId="ADAL" clId="{E9883B15-7D20-4C63-9A3F-08E95C9A44CC}" dt="2026-08-03T14:04:07.557" v="420" actId="20577"/>
           <ac:spMkLst>
@@ -190,37 +182,13 @@
             <ac:spMk id="18" creationId="{26E1E465-28AF-D8E4-07C5-26E76DBB721D}"/>
           </ac:spMkLst>
         </pc:spChg>
-        <pc:grpChg chg="del">
-          <ac:chgData name="Frederik Rask Dalby" userId="12c7c68b-47c4-4858-a883-dbd84be7356f" providerId="ADAL" clId="{E9883B15-7D20-4C63-9A3F-08E95C9A44CC}" dt="2026-08-03T14:03:40.801" v="381" actId="478"/>
-          <ac:grpSpMkLst>
-            <pc:docMk/>
-            <pc:sldMk cId="2126172265" sldId="257"/>
-            <ac:grpSpMk id="17" creationId="{7B559475-ED4E-E23B-A807-B4483EFC5DEE}"/>
-          </ac:grpSpMkLst>
-        </pc:grpChg>
-        <pc:picChg chg="del mod modCrop">
-          <ac:chgData name="Frederik Rask Dalby" userId="12c7c68b-47c4-4858-a883-dbd84be7356f" providerId="ADAL" clId="{E9883B15-7D20-4C63-9A3F-08E95C9A44CC}" dt="2026-08-03T14:03:36.131" v="380" actId="478"/>
-          <ac:picMkLst>
-            <pc:docMk/>
-            <pc:sldMk cId="2126172265" sldId="257"/>
-            <ac:picMk id="5" creationId="{790C6BC8-69F9-33CC-04C5-0EDCF0979AB6}"/>
-          </ac:picMkLst>
-        </pc:picChg>
       </pc:sldChg>
-      <pc:sldChg chg="addSp delSp modSp mod delAnim modAnim">
-        <pc:chgData name="Frederik Rask Dalby" userId="12c7c68b-47c4-4858-a883-dbd84be7356f" providerId="ADAL" clId="{E9883B15-7D20-4C63-9A3F-08E95C9A44CC}" dt="2026-08-03T14:03:56.599" v="385" actId="478"/>
+      <pc:sldChg chg="addSp delSp modSp mod ord delAnim modAnim">
+        <pc:chgData name="Frederik Rask Dalby" userId="12c7c68b-47c4-4858-a883-dbd84be7356f" providerId="ADAL" clId="{E9883B15-7D20-4C63-9A3F-08E95C9A44CC}" dt="2026-08-19T08:53:59.083" v="435" actId="20578"/>
         <pc:sldMkLst>
           <pc:docMk/>
           <pc:sldMk cId="3593674032" sldId="258"/>
         </pc:sldMkLst>
-        <pc:spChg chg="add del mod">
-          <ac:chgData name="Frederik Rask Dalby" userId="12c7c68b-47c4-4858-a883-dbd84be7356f" providerId="ADAL" clId="{E9883B15-7D20-4C63-9A3F-08E95C9A44CC}" dt="2026-08-03T14:03:56.599" v="385" actId="478"/>
-          <ac:spMkLst>
-            <pc:docMk/>
-            <pc:sldMk cId="3593674032" sldId="258"/>
-            <ac:spMk id="3" creationId="{B1BDEEE9-831F-9B8F-B26C-B65B58DB3ABA}"/>
-          </ac:spMkLst>
-        </pc:spChg>
       </pc:sldChg>
       <pc:sldChg chg="addSp modSp mod">
         <pc:chgData name="Frederik Rask Dalby" userId="12c7c68b-47c4-4858-a883-dbd84be7356f" providerId="ADAL" clId="{E9883B15-7D20-4C63-9A3F-08E95C9A44CC}" dt="2026-08-03T14:05:27.660" v="432" actId="1076"/>
@@ -259,36 +227,12 @@
             <ac:spMk id="3" creationId="{04B07399-757B-ECF1-BACF-AA7C8A2C2142}"/>
           </ac:spMkLst>
         </pc:spChg>
-        <pc:spChg chg="del mod">
-          <ac:chgData name="Frederik Rask Dalby" userId="12c7c68b-47c4-4858-a883-dbd84be7356f" providerId="ADAL" clId="{E9883B15-7D20-4C63-9A3F-08E95C9A44CC}" dt="2026-08-03T13:56:42.249" v="265" actId="478"/>
-          <ac:spMkLst>
-            <pc:docMk/>
-            <pc:sldMk cId="2347415508" sldId="263"/>
-            <ac:spMk id="10" creationId="{745D9C9D-F39D-CE27-0D93-B97C2CACD8C4}"/>
-          </ac:spMkLst>
-        </pc:spChg>
-        <pc:spChg chg="del">
-          <ac:chgData name="Frederik Rask Dalby" userId="12c7c68b-47c4-4858-a883-dbd84be7356f" providerId="ADAL" clId="{E9883B15-7D20-4C63-9A3F-08E95C9A44CC}" dt="2026-08-03T14:00:19.770" v="283" actId="478"/>
-          <ac:spMkLst>
-            <pc:docMk/>
-            <pc:sldMk cId="2347415508" sldId="263"/>
-            <ac:spMk id="26" creationId="{29A93565-B9B6-8443-ABF9-C96D096F9BF0}"/>
-          </ac:spMkLst>
-        </pc:spChg>
         <pc:picChg chg="add mod">
           <ac:chgData name="Frederik Rask Dalby" userId="12c7c68b-47c4-4858-a883-dbd84be7356f" providerId="ADAL" clId="{E9883B15-7D20-4C63-9A3F-08E95C9A44CC}" dt="2026-08-03T14:00:26.596" v="285" actId="1076"/>
           <ac:picMkLst>
             <pc:docMk/>
             <pc:sldMk cId="2347415508" sldId="263"/>
             <ac:picMk id="4" creationId="{7972FBE2-74C7-5A3C-18EB-A7E7E64EB84B}"/>
-          </ac:picMkLst>
-        </pc:picChg>
-        <pc:picChg chg="add del">
-          <ac:chgData name="Frederik Rask Dalby" userId="12c7c68b-47c4-4858-a883-dbd84be7356f" providerId="ADAL" clId="{E9883B15-7D20-4C63-9A3F-08E95C9A44CC}" dt="2026-08-03T13:58:59.021" v="276" actId="478"/>
-          <ac:picMkLst>
-            <pc:docMk/>
-            <pc:sldMk cId="2347415508" sldId="263"/>
-            <ac:picMk id="5" creationId="{FEBC598A-C79E-0E5D-B72B-9E912A37B64E}"/>
           </ac:picMkLst>
         </pc:picChg>
         <pc:picChg chg="add mod">
@@ -332,13 +276,21 @@
         </pc:spChg>
       </pc:sldChg>
       <pc:sldChg chg="addSp delSp modSp mod">
-        <pc:chgData name="Frederik Rask Dalby" userId="12c7c68b-47c4-4858-a883-dbd84be7356f" providerId="ADAL" clId="{E9883B15-7D20-4C63-9A3F-08E95C9A44CC}" dt="2026-08-03T12:18:45.634" v="10" actId="1076"/>
+        <pc:chgData name="Frederik Rask Dalby" userId="12c7c68b-47c4-4858-a883-dbd84be7356f" providerId="ADAL" clId="{E9883B15-7D20-4C63-9A3F-08E95C9A44CC}" dt="2026-08-19T08:55:01.348" v="452"/>
         <pc:sldMkLst>
           <pc:docMk/>
           <pc:sldMk cId="2748233568" sldId="268"/>
         </pc:sldMkLst>
         <pc:spChg chg="add mod">
-          <ac:chgData name="Frederik Rask Dalby" userId="12c7c68b-47c4-4858-a883-dbd84be7356f" providerId="ADAL" clId="{E9883B15-7D20-4C63-9A3F-08E95C9A44CC}" dt="2026-08-03T12:18:45.634" v="10" actId="1076"/>
+          <ac:chgData name="Frederik Rask Dalby" userId="12c7c68b-47c4-4858-a883-dbd84be7356f" providerId="ADAL" clId="{E9883B15-7D20-4C63-9A3F-08E95C9A44CC}" dt="2026-08-19T08:54:49.755" v="451" actId="1076"/>
+          <ac:spMkLst>
+            <pc:docMk/>
+            <pc:sldMk cId="2748233568" sldId="268"/>
+            <ac:spMk id="5" creationId="{62F47C8B-2D97-48F7-D378-D3DEACFAC6CE}"/>
+          </ac:spMkLst>
+        </pc:spChg>
+        <pc:spChg chg="add mod">
+          <ac:chgData name="Frederik Rask Dalby" userId="12c7c68b-47c4-4858-a883-dbd84be7356f" providerId="ADAL" clId="{E9883B15-7D20-4C63-9A3F-08E95C9A44CC}" dt="2026-08-19T08:55:01.348" v="452"/>
           <ac:spMkLst>
             <pc:docMk/>
             <pc:sldMk cId="2748233568" sldId="268"/>
@@ -353,21 +305,6 @@
             <ac:picMk id="3" creationId="{8402D9A2-42B8-A0DC-7D1F-595069DB2EB4}"/>
           </ac:picMkLst>
         </pc:picChg>
-        <pc:picChg chg="del">
-          <ac:chgData name="Frederik Rask Dalby" userId="12c7c68b-47c4-4858-a883-dbd84be7356f" providerId="ADAL" clId="{E9883B15-7D20-4C63-9A3F-08E95C9A44CC}" dt="2026-08-03T12:13:16.709" v="2" actId="478"/>
-          <ac:picMkLst>
-            <pc:docMk/>
-            <pc:sldMk cId="2748233568" sldId="268"/>
-            <ac:picMk id="4" creationId="{B033F64C-E494-E5CD-DFDF-612D5A6E49E8}"/>
-          </ac:picMkLst>
-        </pc:picChg>
-      </pc:sldChg>
-      <pc:sldChg chg="del">
-        <pc:chgData name="Frederik Rask Dalby" userId="12c7c68b-47c4-4858-a883-dbd84be7356f" providerId="ADAL" clId="{E9883B15-7D20-4C63-9A3F-08E95C9A44CC}" dt="2026-08-03T12:12:49.160" v="1" actId="47"/>
-        <pc:sldMkLst>
-          <pc:docMk/>
-          <pc:sldMk cId="326724469" sldId="269"/>
-        </pc:sldMkLst>
       </pc:sldChg>
       <pc:sldChg chg="addSp modSp new mod ord">
         <pc:chgData name="Frederik Rask Dalby" userId="12c7c68b-47c4-4858-a883-dbd84be7356f" providerId="ADAL" clId="{E9883B15-7D20-4C63-9A3F-08E95C9A44CC}" dt="2026-08-03T12:25:06.137" v="249" actId="1076"/>
@@ -2670,7 +2607,7 @@
           <a:p>
             <a:fld id="{23AEFBA4-28FC-47E1-9E56-06F4CBE1E155}" type="datetimeFigureOut">
               <a:rPr lang="da-DK" smtClean="0"/>
-              <a:t>03-08-2026</a:t>
+              <a:t>19-08-2026</a:t>
             </a:fld>
             <a:endParaRPr lang="da-DK"/>
           </a:p>
@@ -3465,7 +3402,7 @@
           <a:p>
             <a:fld id="{A563F780-A93D-4912-9E1A-1B58F2D23D1B}" type="datetimeFigureOut">
               <a:rPr lang="da-DK" smtClean="0"/>
-              <a:t>03-08-2026</a:t>
+              <a:t>19-08-2026</a:t>
             </a:fld>
             <a:endParaRPr lang="da-DK"/>
           </a:p>
@@ -3665,7 +3602,7 @@
           <a:p>
             <a:fld id="{A563F780-A93D-4912-9E1A-1B58F2D23D1B}" type="datetimeFigureOut">
               <a:rPr lang="da-DK" smtClean="0"/>
-              <a:t>03-08-2026</a:t>
+              <a:t>19-08-2026</a:t>
             </a:fld>
             <a:endParaRPr lang="da-DK"/>
           </a:p>
@@ -3875,7 +3812,7 @@
           <a:p>
             <a:fld id="{A563F780-A93D-4912-9E1A-1B58F2D23D1B}" type="datetimeFigureOut">
               <a:rPr lang="da-DK" smtClean="0"/>
-              <a:t>03-08-2026</a:t>
+              <a:t>19-08-2026</a:t>
             </a:fld>
             <a:endParaRPr lang="da-DK"/>
           </a:p>
@@ -4075,7 +4012,7 @@
           <a:p>
             <a:fld id="{A563F780-A93D-4912-9E1A-1B58F2D23D1B}" type="datetimeFigureOut">
               <a:rPr lang="da-DK" smtClean="0"/>
-              <a:t>03-08-2026</a:t>
+              <a:t>19-08-2026</a:t>
             </a:fld>
             <a:endParaRPr lang="da-DK"/>
           </a:p>
@@ -4351,7 +4288,7 @@
           <a:p>
             <a:fld id="{A563F780-A93D-4912-9E1A-1B58F2D23D1B}" type="datetimeFigureOut">
               <a:rPr lang="da-DK" smtClean="0"/>
-              <a:t>03-08-2026</a:t>
+              <a:t>19-08-2026</a:t>
             </a:fld>
             <a:endParaRPr lang="da-DK"/>
           </a:p>
@@ -4619,7 +4556,7 @@
           <a:p>
             <a:fld id="{A563F780-A93D-4912-9E1A-1B58F2D23D1B}" type="datetimeFigureOut">
               <a:rPr lang="da-DK" smtClean="0"/>
-              <a:t>03-08-2026</a:t>
+              <a:t>19-08-2026</a:t>
             </a:fld>
             <a:endParaRPr lang="da-DK"/>
           </a:p>
@@ -5034,7 +4971,7 @@
           <a:p>
             <a:fld id="{A563F780-A93D-4912-9E1A-1B58F2D23D1B}" type="datetimeFigureOut">
               <a:rPr lang="da-DK" smtClean="0"/>
-              <a:t>03-08-2026</a:t>
+              <a:t>19-08-2026</a:t>
             </a:fld>
             <a:endParaRPr lang="da-DK"/>
           </a:p>
@@ -5176,7 +5113,7 @@
           <a:p>
             <a:fld id="{A563F780-A93D-4912-9E1A-1B58F2D23D1B}" type="datetimeFigureOut">
               <a:rPr lang="da-DK" smtClean="0"/>
-              <a:t>03-08-2026</a:t>
+              <a:t>19-08-2026</a:t>
             </a:fld>
             <a:endParaRPr lang="da-DK"/>
           </a:p>
@@ -5289,7 +5226,7 @@
           <a:p>
             <a:fld id="{A563F780-A93D-4912-9E1A-1B58F2D23D1B}" type="datetimeFigureOut">
               <a:rPr lang="da-DK" smtClean="0"/>
-              <a:t>03-08-2026</a:t>
+              <a:t>19-08-2026</a:t>
             </a:fld>
             <a:endParaRPr lang="da-DK"/>
           </a:p>
@@ -5602,7 +5539,7 @@
           <a:p>
             <a:fld id="{A563F780-A93D-4912-9E1A-1B58F2D23D1B}" type="datetimeFigureOut">
               <a:rPr lang="da-DK" smtClean="0"/>
-              <a:t>03-08-2026</a:t>
+              <a:t>19-08-2026</a:t>
             </a:fld>
             <a:endParaRPr lang="da-DK"/>
           </a:p>
@@ -5891,7 +5828,7 @@
           <a:p>
             <a:fld id="{A563F780-A93D-4912-9E1A-1B58F2D23D1B}" type="datetimeFigureOut">
               <a:rPr lang="da-DK" smtClean="0"/>
-              <a:t>03-08-2026</a:t>
+              <a:t>19-08-2026</a:t>
             </a:fld>
             <a:endParaRPr lang="da-DK"/>
           </a:p>
@@ -6134,7 +6071,7 @@
           <a:p>
             <a:fld id="{A563F780-A93D-4912-9E1A-1B58F2D23D1B}" type="datetimeFigureOut">
               <a:rPr lang="da-DK" smtClean="0"/>
-              <a:t>03-08-2026</a:t>
+              <a:t>19-08-2026</a:t>
             </a:fld>
             <a:endParaRPr lang="da-DK"/>
           </a:p>
@@ -9261,6 +9198,45 @@
               <a:rPr lang="da-DK" sz="2800" dirty="0"/>
               <a:t>https://www.menti.com/al4yuib4sox4</a:t>
             </a:r>
+          </a:p>
+        </p:txBody>
+      </p:sp>
+      <p:sp>
+        <p:nvSpPr>
+          <p:cNvPr id="5" name="TextBox 4">
+            <a:extLst>
+              <a:ext uri="{FF2B5EF4-FFF2-40B4-BE49-F238E27FC236}">
+                <a16:creationId xmlns:a16="http://schemas.microsoft.com/office/drawing/2014/main" id="{62F47C8B-2D97-48F7-D378-D3DEACFAC6CE}"/>
+              </a:ext>
+            </a:extLst>
+          </p:cNvPr>
+          <p:cNvSpPr txBox="1"/>
+          <p:nvPr/>
+        </p:nvSpPr>
+        <p:spPr>
+          <a:xfrm>
+            <a:off x="9078339" y="2087563"/>
+            <a:ext cx="2382151" cy="646331"/>
+          </a:xfrm>
+          <a:prstGeom prst="rect">
+            <a:avLst/>
+          </a:prstGeom>
+          <a:noFill/>
+        </p:spPr>
+        <p:txBody>
+          <a:bodyPr wrap="square">
+            <a:spAutoFit/>
+          </a:bodyPr>
+          <a:lstStyle/>
+          <a:p>
+            <a:r>
+              <a:rPr lang="da-DK" sz="3600" b="1" i="0" dirty="0">
+                <a:effectLst/>
+                <a:latin typeface="MentiText"/>
+              </a:rPr>
+              <a:t>3494 9134</a:t>
+            </a:r>
+            <a:endParaRPr lang="da-DK" dirty="0"/>
           </a:p>
         </p:txBody>
       </p:sp>
@@ -18800,8 +18776,8 @@
           </a:p>
         </p:txBody>
       </p:sp>
-      <mc:AlternateContent xmlns:mc="http://schemas.openxmlformats.org/markup-compatibility/2006">
-        <mc:Choice xmlns:a14="http://schemas.microsoft.com/office/drawing/2010/main" Requires="a14">
+      <mc:AlternateContent xmlns:mc="http://schemas.openxmlformats.org/markup-compatibility/2006" xmlns:a14="http://schemas.microsoft.com/office/drawing/2010/main">
+        <mc:Choice Requires="a14">
           <p:sp>
             <p:nvSpPr>
               <p:cNvPr id="3" name="Content Placeholder 2">
@@ -19551,7 +19527,7 @@
             </p:txBody>
           </p:sp>
         </mc:Choice>
-        <mc:Fallback>
+        <mc:Fallback xmlns="">
           <p:sp>
             <p:nvSpPr>
               <p:cNvPr id="3" name="Content Placeholder 2">

</xml_diff>